<commit_message>
docs(slides): 重 build pptx（補上 What-if 修正）
</commit_message>
<xml_diff>
--- a/docs/串連系統_簡報.pptx
+++ b/docs/串連系統_簡報.pptx
@@ -3654,7 +3654,7 @@
                 </a:solidFill>
                 <a:latin typeface="Microsoft JhengHei"/>
               </a:rPr>
-              <a:t>不用真的改人事，先模擬看看</a:t>
+              <a:t>「如果我這樣調整，組織健康度會變怎樣？」 — 不用真的執行就能試</a:t>
             </a:r>
           </a:p>
         </p:txBody>
@@ -3667,8 +3667,8 @@
         </p:nvSpPr>
         <p:spPr>
           <a:xfrm>
-            <a:off x="731520" y="2286000"/>
-            <a:ext cx="3566160" cy="2194560"/>
+            <a:off x="518007" y="2194560"/>
+            <a:ext cx="2651760" cy="2194560"/>
           </a:xfrm>
           <a:prstGeom prst="roundRect">
             <a:avLst>
@@ -3712,8 +3712,8 @@
         </p:nvSpPr>
         <p:spPr>
           <a:xfrm>
-            <a:off x="1005840" y="2560320"/>
-            <a:ext cx="3017520" cy="548640"/>
+            <a:off x="792327" y="2468880"/>
+            <a:ext cx="2103120" cy="457200"/>
           </a:xfrm>
           <a:prstGeom prst="rect">
             <a:avLst/>
@@ -3738,7 +3738,7 @@
                 </a:solidFill>
                 <a:latin typeface="Microsoft JhengHei"/>
               </a:rPr>
-              <a:t>Step 1</a:t>
+              <a:t>01</a:t>
             </a:r>
           </a:p>
         </p:txBody>
@@ -3751,8 +3751,8 @@
         </p:nvSpPr>
         <p:spPr>
           <a:xfrm>
-            <a:off x="1005840" y="3063240"/>
-            <a:ext cx="3017520" cy="640080"/>
+            <a:off x="792327" y="2880360"/>
+            <a:ext cx="2103120" cy="548640"/>
           </a:xfrm>
           <a:prstGeom prst="rect">
             <a:avLst/>
@@ -3771,13 +3771,13 @@
               </a:lnSpc>
             </a:pPr>
             <a:r>
-              <a:rPr sz="1800" b="1">
-                <a:solidFill>
-                  <a:srgbClr val="0F172A"/>
-                </a:solidFill>
-                <a:latin typeface="Microsoft JhengHei"/>
-              </a:rPr>
-              <a:t>拖員工到別組</a:t>
+              <a:rPr sz="2200" b="1">
+                <a:solidFill>
+                  <a:srgbClr val="0F172A"/>
+                </a:solidFill>
+                <a:latin typeface="Microsoft JhengHei"/>
+              </a:rPr>
+              <a:t>解卡點</a:t>
             </a:r>
           </a:p>
         </p:txBody>
@@ -3790,33 +3790,49 @@
         </p:nvSpPr>
         <p:spPr>
           <a:xfrm>
-            <a:off x="1005840" y="3840480"/>
-            <a:ext cx="3017520" cy="548640"/>
-          </a:xfrm>
-          <a:prstGeom prst="rect">
-            <a:avLst/>
-          </a:prstGeom>
-          <a:noFill/>
-        </p:spPr>
-        <p:txBody>
-          <a:bodyPr wrap="square" lIns="0" rIns="0" tIns="0" bIns="0" anchor="t">
-            <a:spAutoFit/>
-          </a:bodyPr>
-          <a:lstStyle/>
-          <a:p>
-            <a:pPr algn="l">
-              <a:lnSpc>
-                <a:spcPct val="120000"/>
-              </a:lnSpc>
-            </a:pPr>
-            <a:r>
-              <a:rPr sz="1200" b="0">
+            <a:off x="792327" y="3474720"/>
+            <a:ext cx="2103120" cy="822960"/>
+          </a:xfrm>
+          <a:prstGeom prst="rect">
+            <a:avLst/>
+          </a:prstGeom>
+          <a:noFill/>
+        </p:spPr>
+        <p:txBody>
+          <a:bodyPr wrap="square" lIns="0" rIns="0" tIns="0" bIns="0" anchor="t">
+            <a:spAutoFit/>
+          </a:bodyPr>
+          <a:lstStyle/>
+          <a:p>
+            <a:pPr algn="l">
+              <a:lnSpc>
+                <a:spcPct val="145000"/>
+              </a:lnSpc>
+            </a:pPr>
+            <a:r>
+              <a:rPr sz="1150" b="0">
                 <a:solidFill>
                   <a:srgbClr val="64748B"/>
                 </a:solidFill>
                 <a:latin typeface="Microsoft JhengHei"/>
               </a:rPr>
-              <a:t>用滑鼠拖一拖就好</a:t>
+              <a:t>勾選哪些卡點</a:t>
+            </a:r>
+          </a:p>
+          <a:p>
+            <a:pPr algn="l">
+              <a:lnSpc>
+                <a:spcPct val="145000"/>
+              </a:lnSpc>
+            </a:pPr>
+            <a:r>
+              <a:rPr sz="1150" b="0">
+                <a:solidFill>
+                  <a:srgbClr val="64748B"/>
+                </a:solidFill>
+                <a:latin typeface="Microsoft JhengHei"/>
+              </a:rPr>
+              <a:t>「假設已解決」</a:t>
             </a:r>
           </a:p>
         </p:txBody>
@@ -3829,8 +3845,8 @@
         </p:nvSpPr>
         <p:spPr>
           <a:xfrm>
-            <a:off x="4526280" y="2286000"/>
-            <a:ext cx="3566160" cy="2194560"/>
+            <a:off x="3352647" y="2194560"/>
+            <a:ext cx="2651760" cy="2194560"/>
           </a:xfrm>
           <a:prstGeom prst="roundRect">
             <a:avLst>
@@ -3874,8 +3890,8 @@
         </p:nvSpPr>
         <p:spPr>
           <a:xfrm>
-            <a:off x="4800600" y="2560320"/>
-            <a:ext cx="3017520" cy="548640"/>
+            <a:off x="3626967" y="2468880"/>
+            <a:ext cx="2103120" cy="457200"/>
           </a:xfrm>
           <a:prstGeom prst="rect">
             <a:avLst/>
@@ -3900,7 +3916,7 @@
                 </a:solidFill>
                 <a:latin typeface="Microsoft JhengHei"/>
               </a:rPr>
-              <a:t>Step 2</a:t>
+              <a:t>02</a:t>
             </a:r>
           </a:p>
         </p:txBody>
@@ -3913,8 +3929,8 @@
         </p:nvSpPr>
         <p:spPr>
           <a:xfrm>
-            <a:off x="4800600" y="3063240"/>
-            <a:ext cx="3017520" cy="640080"/>
+            <a:off x="3626967" y="2880360"/>
+            <a:ext cx="2103120" cy="548640"/>
           </a:xfrm>
           <a:prstGeom prst="rect">
             <a:avLst/>
@@ -3933,13 +3949,13 @@
               </a:lnSpc>
             </a:pPr>
             <a:r>
-              <a:rPr sz="1800" b="1">
-                <a:solidFill>
-                  <a:srgbClr val="0F172A"/>
-                </a:solidFill>
-                <a:latin typeface="Microsoft JhengHei"/>
-              </a:rPr>
-              <a:t>即時看分佈</a:t>
+              <a:rPr sz="2200" b="1">
+                <a:solidFill>
+                  <a:srgbClr val="0F172A"/>
+                </a:solidFill>
+                <a:latin typeface="Microsoft JhengHei"/>
+              </a:rPr>
+              <a:t>加速決策</a:t>
             </a:r>
           </a:p>
         </p:txBody>
@@ -3952,33 +3968,49 @@
         </p:nvSpPr>
         <p:spPr>
           <a:xfrm>
-            <a:off x="4800600" y="3840480"/>
-            <a:ext cx="3017520" cy="548640"/>
-          </a:xfrm>
-          <a:prstGeom prst="rect">
-            <a:avLst/>
-          </a:prstGeom>
-          <a:noFill/>
-        </p:spPr>
-        <p:txBody>
-          <a:bodyPr wrap="square" lIns="0" rIns="0" tIns="0" bIns="0" anchor="t">
-            <a:spAutoFit/>
-          </a:bodyPr>
-          <a:lstStyle/>
-          <a:p>
-            <a:pPr algn="l">
-              <a:lnSpc>
-                <a:spcPct val="120000"/>
-              </a:lnSpc>
-            </a:pPr>
-            <a:r>
-              <a:rPr sz="1200" b="0">
+            <a:off x="3626967" y="3474720"/>
+            <a:ext cx="2103120" cy="822960"/>
+          </a:xfrm>
+          <a:prstGeom prst="rect">
+            <a:avLst/>
+          </a:prstGeom>
+          <a:noFill/>
+        </p:spPr>
+        <p:txBody>
+          <a:bodyPr wrap="square" lIns="0" rIns="0" tIns="0" bIns="0" anchor="t">
+            <a:spAutoFit/>
+          </a:bodyPr>
+          <a:lstStyle/>
+          <a:p>
+            <a:pPr algn="l">
+              <a:lnSpc>
+                <a:spcPct val="145000"/>
+              </a:lnSpc>
+            </a:pPr>
+            <a:r>
+              <a:rPr sz="1150" b="0">
                 <a:solidFill>
                   <a:srgbClr val="64748B"/>
                 </a:solidFill>
                 <a:latin typeface="Microsoft JhengHei"/>
               </a:rPr>
-              <a:t>Gini 變了？誰過載？</a:t>
+              <a:t>勾選哪些逾期決策</a:t>
+            </a:r>
+          </a:p>
+          <a:p>
+            <a:pPr algn="l">
+              <a:lnSpc>
+                <a:spcPct val="145000"/>
+              </a:lnSpc>
+            </a:pPr>
+            <a:r>
+              <a:rPr sz="1150" b="0">
+                <a:solidFill>
+                  <a:srgbClr val="64748B"/>
+                </a:solidFill>
+                <a:latin typeface="Microsoft JhengHei"/>
+              </a:rPr>
+              <a:t>「假設立刻完成」</a:t>
             </a:r>
           </a:p>
         </p:txBody>
@@ -3991,8 +4023,8 @@
         </p:nvSpPr>
         <p:spPr>
           <a:xfrm>
-            <a:off x="8321040" y="2286000"/>
-            <a:ext cx="3566160" cy="2194560"/>
+            <a:off x="6187287" y="2194560"/>
+            <a:ext cx="2651760" cy="2194560"/>
           </a:xfrm>
           <a:prstGeom prst="roundRect">
             <a:avLst>
@@ -4036,8 +4068,8 @@
         </p:nvSpPr>
         <p:spPr>
           <a:xfrm>
-            <a:off x="8595360" y="2560320"/>
-            <a:ext cx="3017520" cy="548640"/>
+            <a:off x="6461607" y="2468880"/>
+            <a:ext cx="2103120" cy="457200"/>
           </a:xfrm>
           <a:prstGeom prst="rect">
             <a:avLst/>
@@ -4062,7 +4094,7 @@
                 </a:solidFill>
                 <a:latin typeface="Microsoft JhengHei"/>
               </a:rPr>
-              <a:t>Step 3</a:t>
+              <a:t>03</a:t>
             </a:r>
           </a:p>
         </p:txBody>
@@ -4075,8 +4107,8 @@
         </p:nvSpPr>
         <p:spPr>
           <a:xfrm>
-            <a:off x="8595360" y="3063240"/>
-            <a:ext cx="3017520" cy="640080"/>
+            <a:off x="6461607" y="2880360"/>
+            <a:ext cx="2103120" cy="548640"/>
           </a:xfrm>
           <a:prstGeom prst="rect">
             <a:avLst/>
@@ -4095,13 +4127,13 @@
               </a:lnSpc>
             </a:pPr>
             <a:r>
-              <a:rPr sz="1800" b="1">
-                <a:solidFill>
-                  <a:srgbClr val="0F172A"/>
-                </a:solidFill>
-                <a:latin typeface="Microsoft JhengHei"/>
-              </a:rPr>
-              <a:t>系統給建議</a:t>
+              <a:rPr sz="2200" b="1">
+                <a:solidFill>
+                  <a:srgbClr val="0F172A"/>
+                </a:solidFill>
+                <a:latin typeface="Microsoft JhengHei"/>
+              </a:rPr>
+              <a:t>簽收交接</a:t>
             </a:r>
           </a:p>
         </p:txBody>
@@ -4114,33 +4146,49 @@
         </p:nvSpPr>
         <p:spPr>
           <a:xfrm>
-            <a:off x="8595360" y="3840480"/>
-            <a:ext cx="3017520" cy="548640"/>
-          </a:xfrm>
-          <a:prstGeom prst="rect">
-            <a:avLst/>
-          </a:prstGeom>
-          <a:noFill/>
-        </p:spPr>
-        <p:txBody>
-          <a:bodyPr wrap="square" lIns="0" rIns="0" tIns="0" bIns="0" anchor="t">
-            <a:spAutoFit/>
-          </a:bodyPr>
-          <a:lstStyle/>
-          <a:p>
-            <a:pPr algn="l">
-              <a:lnSpc>
-                <a:spcPct val="120000"/>
-              </a:lnSpc>
-            </a:pPr>
-            <a:r>
-              <a:rPr sz="1200" b="0">
+            <a:off x="6461607" y="3474720"/>
+            <a:ext cx="2103120" cy="822960"/>
+          </a:xfrm>
+          <a:prstGeom prst="rect">
+            <a:avLst/>
+          </a:prstGeom>
+          <a:noFill/>
+        </p:spPr>
+        <p:txBody>
+          <a:bodyPr wrap="square" lIns="0" rIns="0" tIns="0" bIns="0" anchor="t">
+            <a:spAutoFit/>
+          </a:bodyPr>
+          <a:lstStyle/>
+          <a:p>
+            <a:pPr algn="l">
+              <a:lnSpc>
+                <a:spcPct val="145000"/>
+              </a:lnSpc>
+            </a:pPr>
+            <a:r>
+              <a:rPr sz="1150" b="0">
                 <a:solidFill>
                   <a:srgbClr val="64748B"/>
                 </a:solidFill>
                 <a:latin typeface="Microsoft JhengHei"/>
               </a:rPr>
-              <a:t>「把 X 移到 Y 組會更平均」</a:t>
+              <a:t>勾選哪些交接</a:t>
+            </a:r>
+          </a:p>
+          <a:p>
+            <a:pPr algn="l">
+              <a:lnSpc>
+                <a:spcPct val="145000"/>
+              </a:lnSpc>
+            </a:pPr>
+            <a:r>
+              <a:rPr sz="1150" b="0">
+                <a:solidFill>
+                  <a:srgbClr val="64748B"/>
+                </a:solidFill>
+                <a:latin typeface="Microsoft JhengHei"/>
+              </a:rPr>
+              <a:t>「假設立刻簽收」</a:t>
             </a:r>
           </a:p>
         </p:txBody>
@@ -4153,12 +4201,12 @@
         </p:nvSpPr>
         <p:spPr>
           <a:xfrm>
-            <a:off x="731520" y="4846320"/>
-            <a:ext cx="10698480" cy="1371600"/>
+            <a:off x="9021927" y="2194560"/>
+            <a:ext cx="2651760" cy="2194560"/>
           </a:xfrm>
           <a:prstGeom prst="roundRect">
             <a:avLst>
-              <a:gd name="adj" fmla="val 10000"/>
+              <a:gd name="adj" fmla="val 6000"/>
             </a:avLst>
           </a:prstGeom>
           <a:noFill/>
@@ -4198,7 +4246,185 @@
         </p:nvSpPr>
         <p:spPr>
           <a:xfrm>
-            <a:off x="914400" y="5029200"/>
+            <a:off x="9296247" y="2468880"/>
+            <a:ext cx="2103120" cy="457200"/>
+          </a:xfrm>
+          <a:prstGeom prst="rect">
+            <a:avLst/>
+          </a:prstGeom>
+          <a:noFill/>
+        </p:spPr>
+        <p:txBody>
+          <a:bodyPr wrap="square" lIns="0" rIns="0" tIns="0" bIns="0" anchor="t">
+            <a:spAutoFit/>
+          </a:bodyPr>
+          <a:lstStyle/>
+          <a:p>
+            <a:pPr algn="l">
+              <a:lnSpc>
+                <a:spcPct val="120000"/>
+              </a:lnSpc>
+            </a:pPr>
+            <a:r>
+              <a:rPr sz="1400" b="1">
+                <a:solidFill>
+                  <a:srgbClr val="0F172A"/>
+                </a:solidFill>
+                <a:latin typeface="Microsoft JhengHei"/>
+              </a:rPr>
+              <a:t>04</a:t>
+            </a:r>
+          </a:p>
+        </p:txBody>
+      </p:sp>
+      <p:sp>
+        <p:nvSpPr>
+          <p:cNvPr id="21" name="TextBox 20"/>
+          <p:cNvSpPr txBox="1"/>
+          <p:nvPr/>
+        </p:nvSpPr>
+        <p:spPr>
+          <a:xfrm>
+            <a:off x="9296247" y="2880360"/>
+            <a:ext cx="2103120" cy="548640"/>
+          </a:xfrm>
+          <a:prstGeom prst="rect">
+            <a:avLst/>
+          </a:prstGeom>
+          <a:noFill/>
+        </p:spPr>
+        <p:txBody>
+          <a:bodyPr wrap="square" lIns="0" rIns="0" tIns="0" bIns="0" anchor="t">
+            <a:spAutoFit/>
+          </a:bodyPr>
+          <a:lstStyle/>
+          <a:p>
+            <a:pPr algn="l">
+              <a:lnSpc>
+                <a:spcPct val="130000"/>
+              </a:lnSpc>
+            </a:pPr>
+            <a:r>
+              <a:rPr sz="2200" b="1">
+                <a:solidFill>
+                  <a:srgbClr val="0F172A"/>
+                </a:solidFill>
+                <a:latin typeface="Microsoft JhengHei"/>
+              </a:rPr>
+              <a:t>降低負載</a:t>
+            </a:r>
+          </a:p>
+        </p:txBody>
+      </p:sp>
+      <p:sp>
+        <p:nvSpPr>
+          <p:cNvPr id="22" name="TextBox 21"/>
+          <p:cNvSpPr txBox="1"/>
+          <p:nvPr/>
+        </p:nvSpPr>
+        <p:spPr>
+          <a:xfrm>
+            <a:off x="9296247" y="3474720"/>
+            <a:ext cx="2103120" cy="822960"/>
+          </a:xfrm>
+          <a:prstGeom prst="rect">
+            <a:avLst/>
+          </a:prstGeom>
+          <a:noFill/>
+        </p:spPr>
+        <p:txBody>
+          <a:bodyPr wrap="square" lIns="0" rIns="0" tIns="0" bIns="0" anchor="t">
+            <a:spAutoFit/>
+          </a:bodyPr>
+          <a:lstStyle/>
+          <a:p>
+            <a:pPr algn="l">
+              <a:lnSpc>
+                <a:spcPct val="145000"/>
+              </a:lnSpc>
+            </a:pPr>
+            <a:r>
+              <a:rPr sz="1150" b="0">
+                <a:solidFill>
+                  <a:srgbClr val="64748B"/>
+                </a:solidFill>
+                <a:latin typeface="Microsoft JhengHei"/>
+              </a:rPr>
+              <a:t>對特定員工</a:t>
+            </a:r>
+          </a:p>
+          <a:p>
+            <a:pPr algn="l">
+              <a:lnSpc>
+                <a:spcPct val="145000"/>
+              </a:lnSpc>
+            </a:pPr>
+            <a:r>
+              <a:rPr sz="1150" b="0">
+                <a:solidFill>
+                  <a:srgbClr val="64748B"/>
+                </a:solidFill>
+                <a:latin typeface="Microsoft JhengHei"/>
+              </a:rPr>
+              <a:t>拉滑桿減 0-80%</a:t>
+            </a:r>
+          </a:p>
+        </p:txBody>
+      </p:sp>
+      <p:sp>
+        <p:nvSpPr>
+          <p:cNvPr id="23" name="Rounded Rectangle 22"/>
+          <p:cNvSpPr/>
+          <p:nvPr/>
+        </p:nvSpPr>
+        <p:spPr>
+          <a:xfrm>
+            <a:off x="731520" y="4754880"/>
+            <a:ext cx="10698480" cy="1463040"/>
+          </a:xfrm>
+          <a:prstGeom prst="roundRect">
+            <a:avLst>
+              <a:gd name="adj" fmla="val 10000"/>
+            </a:avLst>
+          </a:prstGeom>
+          <a:noFill/>
+          <a:ln w="9525">
+            <a:solidFill>
+              <a:srgbClr val="E2E8F0"/>
+            </a:solidFill>
+          </a:ln>
+        </p:spPr>
+        <p:style>
+          <a:lnRef idx="1">
+            <a:schemeClr val="accent1"/>
+          </a:lnRef>
+          <a:fillRef idx="3">
+            <a:schemeClr val="accent1"/>
+          </a:fillRef>
+          <a:effectRef idx="2">
+            <a:schemeClr val="accent1"/>
+          </a:effectRef>
+          <a:fontRef idx="minor">
+            <a:schemeClr val="lt1"/>
+          </a:fontRef>
+        </p:style>
+        <p:txBody>
+          <a:bodyPr rtlCol="0" anchor="ctr"/>
+          <a:lstStyle/>
+          <a:p>
+            <a:pPr algn="ctr"/>
+          </a:p>
+        </p:txBody>
+      </p:sp>
+      <p:sp>
+        <p:nvSpPr>
+          <p:cNvPr id="24" name="TextBox 23"/>
+          <p:cNvSpPr txBox="1"/>
+          <p:nvPr/>
+        </p:nvSpPr>
+        <p:spPr>
+          <a:xfrm>
+            <a:off x="914400" y="4937760"/>
             <a:ext cx="10515600" cy="457200"/>
           </a:xfrm>
           <a:prstGeom prst="rect">
@@ -4224,20 +4450,20 @@
                 </a:solidFill>
                 <a:latin typeface="Microsoft JhengHei"/>
               </a:rPr>
-              <a:t>為什麼這樣設計？</a:t>
-            </a:r>
-          </a:p>
-        </p:txBody>
-      </p:sp>
-      <p:sp>
-        <p:nvSpPr>
-          <p:cNvPr id="21" name="TextBox 20"/>
-          <p:cNvSpPr txBox="1"/>
-          <p:nvPr/>
-        </p:nvSpPr>
-        <p:spPr>
-          <a:xfrm>
-            <a:off x="914400" y="5440680"/>
+              <a:t>系統怎麼回答你「這樣改值不值得」</a:t>
+            </a:r>
+          </a:p>
+        </p:txBody>
+      </p:sp>
+      <p:sp>
+        <p:nvSpPr>
+          <p:cNvPr id="25" name="TextBox 24"/>
+          <p:cNvSpPr txBox="1"/>
+          <p:nvPr/>
+        </p:nvSpPr>
+        <p:spPr>
+          <a:xfrm>
+            <a:off x="914400" y="5349240"/>
             <a:ext cx="10515600" cy="914400"/>
           </a:xfrm>
           <a:prstGeom prst="rect">
@@ -4253,56 +4479,56 @@
           <a:p>
             <a:pPr algn="l">
               <a:lnSpc>
-                <a:spcPct val="150000"/>
-              </a:lnSpc>
-            </a:pPr>
-            <a:r>
-              <a:rPr sz="1300" b="0">
-                <a:solidFill>
-                  <a:srgbClr val="0F172A"/>
-                </a:solidFill>
-                <a:latin typeface="Microsoft JhengHei"/>
-              </a:rPr>
-              <a:t>• 不用真的改人事 — 在「另一條時間線」試試看，反悔不要錢</a:t>
-            </a:r>
-          </a:p>
-          <a:p>
-            <a:pPr algn="l">
-              <a:lnSpc>
-                <a:spcPct val="150000"/>
-              </a:lnSpc>
-            </a:pPr>
-            <a:r>
-              <a:rPr sz="1300" b="0">
-                <a:solidFill>
-                  <a:srgbClr val="0F172A"/>
-                </a:solidFill>
-                <a:latin typeface="Microsoft JhengHei"/>
-              </a:rPr>
-              <a:t>• 拖到哪算到哪 — 拖曳當下就重算，不用等</a:t>
-            </a:r>
-          </a:p>
-          <a:p>
-            <a:pPr algn="l">
-              <a:lnSpc>
-                <a:spcPct val="150000"/>
-              </a:lnSpc>
-            </a:pPr>
-            <a:r>
-              <a:rPr sz="1300" b="0">
-                <a:solidFill>
-                  <a:srgbClr val="0F172A"/>
-                </a:solidFill>
-                <a:latin typeface="Microsoft JhengHei"/>
-              </a:rPr>
-              <a:t>• 系統會主動建議 — 「把蔡明遠移到投研，整體會更平均」</a:t>
-            </a:r>
-          </a:p>
-        </p:txBody>
-      </p:sp>
-      <p:sp>
-        <p:nvSpPr>
-          <p:cNvPr id="22" name="TextBox 21"/>
+                <a:spcPct val="155000"/>
+              </a:lnSpc>
+            </a:pPr>
+            <a:r>
+              <a:rPr sz="1250" b="0">
+                <a:solidFill>
+                  <a:srgbClr val="0F172A"/>
+                </a:solidFill>
+                <a:latin typeface="Microsoft JhengHei"/>
+              </a:rPr>
+              <a:t>• 即時雙雷達圖對比 — 現況 vs 模擬後（同一張圖兩種顏色疊圖）</a:t>
+            </a:r>
+          </a:p>
+          <a:p>
+            <a:pPr algn="l">
+              <a:lnSpc>
+                <a:spcPct val="155000"/>
+              </a:lnSpc>
+            </a:pPr>
+            <a:r>
+              <a:rPr sz="1250" b="0">
+                <a:solidFill>
+                  <a:srgbClr val="0F172A"/>
+                </a:solidFill>
+                <a:latin typeface="Microsoft JhengHei"/>
+              </a:rPr>
+              <a:t>• 健康度 Δ 一個數字 — Δ &gt; 5「強烈建議」、0~5「微改善」、&lt; -5「不建議」</a:t>
+            </a:r>
+          </a:p>
+          <a:p>
+            <a:pPr algn="l">
+              <a:lnSpc>
+                <a:spcPct val="155000"/>
+              </a:lnSpc>
+            </a:pPr>
+            <a:r>
+              <a:rPr sz="1250" b="0">
+                <a:solidFill>
+                  <a:srgbClr val="0F172A"/>
+                </a:solidFill>
+                <a:latin typeface="Microsoft JhengHei"/>
+              </a:rPr>
+              <a:t>• useDeferredValue 確保拖滑桿時不卡 UI（背景重算、前景流暢）</a:t>
+            </a:r>
+          </a:p>
+        </p:txBody>
+      </p:sp>
+      <p:sp>
+        <p:nvSpPr>
+          <p:cNvPr id="26" name="TextBox 25"/>
           <p:cNvSpPr txBox="1"/>
           <p:nvPr/>
         </p:nvSpPr>
@@ -4341,7 +4567,7 @@
       </p:sp>
       <p:sp>
         <p:nvSpPr>
-          <p:cNvPr id="23" name="TextBox 22"/>
+          <p:cNvPr id="27" name="TextBox 26"/>
           <p:cNvSpPr txBox="1"/>
           <p:nvPr/>
         </p:nvSpPr>

</xml_diff>